<commit_message>
Add the rented-to-owned budget shift: three gated tranches from retargeting, search and prospecting
Slide 7, the executive summary, the budget appendix and the numbers register now show retargeting (up to $3.4M = 24.5% x $14M) after day 90, a South branded-search test (~$6.2M) in months 4-6 and a South prospecting test (~$16.2M) in months 7-9, each moving only what its holdout proves.

Co-Authored-By: Claude Opus 5.5 <noreply@anthropic.com>
Claude-Session: https://claude.ai/code/session_01PZ8XgsWarJGqs7eKwNE5g5
</commit_message>
<xml_diff>
--- a/deck/Team G27.pptx
+++ b/deck/Team G27.pptx
@@ -2640,7 +2640,7 @@
           <a:p>
             <a:r>
               <a:rPr lang="en-US" dirty="0"/>
-              <a:t>The 90-day pilot, lever by lever. Lever 1, capture every buyer, runs on SMS at checkout, app order tracking and email reminders: we split consent, build the abandoner segment in CJA and print Passport cards, then launch and measure cart recovery and opt-ins. Lever 2, the golden month, runs on shipping events fed into CJA and Journey Optimizer, sending a care guide at delivery and a second category by day 21; we measure 30-day repeat. Both are paid from Option A's $2 to 3M inside the existing $6M owned line. Lever 3, never pay twice, turns CJA audiences into daily suppression lists through Real-Time CDP for Meta, Google and TikTok, inside the $14M retargeting line at no extra cost. Seven of the 14 programs start in the pilot; the other seven wait for the holdout. Prospecting and search stay untouched; influencer briefs shift to proof. On day 90 we scale, adjust or stop, and any move across budget lines is sized by the holdout.</a:t>
+              <a:t>The 90-day pilot, lever by lever. Lever 1, capture every buyer, runs on SMS at checkout, app order tracking and email reminders: we split consent, build the abandoner segment in CJA and print Passport cards, then launch and measure cart recovery and opt-ins. Lever 2, the golden month, runs on shipping events fed into CJA and Journey Optimizer, sending a care guide at delivery and a second category by day 21; we measure 30-day repeat. Both are paid from Option A's $2 to 3M inside the existing $6M owned line. Lever 3, never pay twice, turns CJA audiences into daily suppression lists through Real-Time CDP for Meta, Google and TikTok, inside the $14M retargeting line at no extra cost. Seven of the 14 programs start in the pilot; the other seven wait for the holdout. Then the money moves from rented to owned in three gated steps. After day 90, retargeting spend on buyers Quince can already reach moves to owned: up to $3.4 million, which is 24.5% of the $14 million line. In months 4 to 6, a South geo test on branded search, about $6.2 million of the $22 million line; in months 7 to 9, a South test on prospecting, about $16.2 million of the $58 million line. Each step moves only what its holdout proves, so the money follows the evidence.</a:t>
             </a:r>
             <a:endParaRPr lang="en-US" dirty="0"/>
           </a:p>
@@ -19987,7 +19987,7 @@
                 <a:ea typeface="Inter" pitchFamily="34" charset="-122"/>
                 <a:cs typeface="Inter" pitchFamily="34" charset="-120"/>
               </a:rPr>
-              <a:t>No new money</a:t>
+              <a:t>No new money: rented → owned</a:t>
             </a:r>
             <a:endParaRPr lang="en-US" sz="1100" dirty="0"/>
           </a:p>
@@ -20082,13 +20082,13 @@
             <a:r>
               <a:rPr lang="en-US" sz="1050" b="1" dirty="0">
                 <a:solidFill>
-                  <a:srgbClr val="0F172A"/>
-                </a:solidFill>
-                <a:latin typeface="Inter" pitchFamily="34" charset="0"/>
-                <a:ea typeface="Inter" pitchFamily="34" charset="-122"/>
-                <a:cs typeface="Inter" pitchFamily="34" charset="-120"/>
-              </a:rPr>
-              <a:t>Nothing else moves without a holdout</a:t>
+                  <a:srgbClr val="0A1F44"/>
+                </a:solidFill>
+                <a:latin typeface="Inter" pitchFamily="34" charset="0"/>
+                <a:ea typeface="Inter" pitchFamily="34" charset="-122"/>
+                <a:cs typeface="Inter" pitchFamily="34" charset="-120"/>
+              </a:rPr>
+              <a:t>Then retargeting → search → prospecting move to owned, as holdouts prove</a:t>
             </a:r>
             <a:endParaRPr lang="en-US" sz="1050" dirty="0"/>
           </a:p>
@@ -22334,7 +22334,7 @@
                 <a:ea typeface="Inter" pitchFamily="34" charset="-122"/>
                 <a:cs typeface="Inter" pitchFamily="34" charset="-120"/>
               </a:rPr>
-              <a:t>How the fixed $120M moves: rules, not guesses</a:t>
+              <a:t>How the fixed $120M moves from rented to owned</a:t>
             </a:r>
             <a:endParaRPr lang="en-US" sz="2400" dirty="0"/>
           </a:p>
@@ -22486,7 +22486,7 @@
                 <a:ea typeface="Inter" pitchFamily="34" charset="-122"/>
                 <a:cs typeface="Inter" pitchFamily="34" charset="-120"/>
               </a:rPr>
-              <a:t>Source: case Exhibits G (budget), I (cost by option), D (channel CAC); Adobe CJA A3b, A2 and Attribution IQ. No cross-line amount is set in advance: a CJA holdout result sets it.</a:t>
+              <a:t>Source: case Exhibits G (budget), I (cost by option), D (channel CAC), N (regions); Adobe CJA A3b, A2 and Attribution IQ. South test sizes assume spend follows the customer split (South 28%); final amounts are what each holdout proves.</a:t>
             </a:r>
             <a:endParaRPr lang="en-US" sz="800" dirty="0"/>
           </a:p>
@@ -22850,7 +22850,7 @@
                 <a:ea typeface="Inter" pitchFamily="34" charset="-122"/>
                 <a:cs typeface="Inter" pitchFamily="34" charset="-120"/>
               </a:rPr>
-              <a:t>Budget unchanged; existing buyers excluded; lookalikes seeded on repeat buyers</a:t>
+              <a:t>Months 7–9: South test on ~$16.2M; existing buyers excluded, lookalikes on repeaters</a:t>
             </a:r>
             <a:endParaRPr lang="en-US" sz="900" dirty="0"/>
           </a:p>
@@ -22889,7 +22889,7 @@
                 <a:ea typeface="Inter" pitchFamily="34" charset="-122"/>
                 <a:cs typeface="Inter" pitchFamily="34" charset="-120"/>
               </a:rPr>
-              <a:t>Brings 45.5% of buyers (CJA A3b)</a:t>
+              <a:t>Brings 45.5% of buyers (A3b) but its buyers repeat least, 18% (Exhibit D)</a:t>
             </a:r>
             <a:endParaRPr lang="en-US" sz="900" dirty="0"/>
           </a:p>
@@ -22928,7 +22928,7 @@
                 <a:ea typeface="Inter" pitchFamily="34" charset="-122"/>
                 <a:cs typeface="Inter" pitchFamily="34" charset="-120"/>
               </a:rPr>
-              <a:t>Moves only if Attribution IQ and a holdout show it is over-credited</a:t>
+              <a:t>Moves to owned only what the holdout shows is over-credited</a:t>
             </a:r>
             <a:endParaRPr lang="en-US" sz="900" dirty="0"/>
           </a:p>
@@ -23097,7 +23097,7 @@
                 <a:ea typeface="Inter" pitchFamily="34" charset="-122"/>
                 <a:cs typeface="Inter" pitchFamily="34" charset="-120"/>
               </a:rPr>
-              <a:t>Unchanged in the pilot</a:t>
+              <a:t>Months 4–6: South geo test on ~$6.2M of branded terms</a:t>
             </a:r>
             <a:endParaRPr lang="en-US" sz="900" dirty="0"/>
           </a:p>
@@ -23175,7 +23175,7 @@
                 <a:ea typeface="Inter" pitchFamily="34" charset="-122"/>
                 <a:cs typeface="Inter" pitchFamily="34" charset="-120"/>
               </a:rPr>
-              <a:t>Geo holdout on branded terms before any move</a:t>
+              <a:t>Non-incremental branded spend moves to owned</a:t>
             </a:r>
             <a:endParaRPr lang="en-US" sz="900" dirty="0"/>
           </a:p>
@@ -23669,7 +23669,7 @@
                 <a:ea typeface="Inter" pitchFamily="34" charset="-122"/>
                 <a:cs typeface="Inter" pitchFamily="34" charset="-120"/>
               </a:rPr>
-              <a:t>$0 incremental (Exhibit I); savings stay in the line until the holdout reads</a:t>
+              <a:t>After day 90: up to $3.4M (24.5% × $14M) moves to owned, as the holdout proves</a:t>
             </a:r>
             <a:endParaRPr lang="en-US" sz="900" dirty="0"/>
           </a:p>
@@ -23916,7 +23916,7 @@
                 <a:ea typeface="Inter" pitchFamily="34" charset="-122"/>
                 <a:cs typeface="Inter" pitchFamily="34" charset="-120"/>
               </a:rPr>
-              <a:t>Funded inside the existing line (Exhibit I)</a:t>
+              <a:t>Receives every proven tranche</a:t>
             </a:r>
             <a:endParaRPr lang="en-US" sz="900" dirty="0"/>
           </a:p>
@@ -24278,7 +24278,7 @@
                 <a:ea typeface="Inter" pitchFamily="34" charset="-122"/>
                 <a:cs typeface="Inter" pitchFamily="34" charset="-120"/>
               </a:rPr>
-              <a:t>Net change: $0. Money crosses lines only when a CJA holdout proves it, and the holdout sets the amount</a:t>
+              <a:t>Net change: $0. Money leaves rented lines in three steps, each sized by what its holdout proves</a:t>
             </a:r>
             <a:endParaRPr lang="en-US" sz="1300" dirty="0"/>
           </a:p>
@@ -35154,7 +35154,7 @@
                 <a:ea typeface="Inter" pitchFamily="34" charset="-122"/>
                 <a:cs typeface="Inter" pitchFamily="34" charset="-120"/>
               </a:rPr>
-              <a:t>Gate pass = minimum effect pre-registered by Analytics; no reallocation amount assumed</a:t>
+              <a:t>$3.4M = 24.5% × $14M; South tests 28% (Exh. N) × $22M = ~$6.2M, × $58M = ~$16.2M</a:t>
             </a:r>
             <a:endParaRPr lang="en-US" sz="850" dirty="0"/>
           </a:p>
@@ -47823,7 +47823,7 @@
                 <a:ea typeface="Inter" pitchFamily="34" charset="-122"/>
                 <a:cs typeface="Inter" pitchFamily="34" charset="-120"/>
               </a:rPr>
-              <a:t>Source: case Exhibits G (budget), I (cost by option), N (regions); Adobe CJA A1, A2, A3b, A6, Cohort Table. Pilot design, timing and program sequencing are the team's. 10% randomized South holdout throughout.</a:t>
+              <a:t>Source: case Exhibits G (budget), I (cost by option), N (regions); Adobe CJA A1, A2, A3b, A6, Cohort Table. Pilot design and sequencing are the team's. South test sizes assume spend follows the customer split (South 28%, Exhibit N). 10% randomized South holdout throughout.</a:t>
             </a:r>
             <a:endParaRPr lang="en-US" sz="800" dirty="0"/>
           </a:p>
@@ -51602,493 +51602,19 @@
       </p:sp>
       <p:sp>
         <p:nvSpPr>
-          <p:cNvPr id="123" name="Text 111"/>
-          <p:cNvSpPr txBox="1"/>
-          <p:nvPr/>
-        </p:nvSpPr>
-        <p:spPr>
-          <a:xfrm>
-            <a:off x="502920" y="5751576"/>
-            <a:ext cx="1508760" cy="566928"/>
-          </a:xfrm>
-          <a:prstGeom prst="rect">
-            <a:avLst/>
-          </a:prstGeom>
-          <a:noFill/>
-          <a:ln/>
-        </p:spPr>
-        <p:txBody>
-          <a:bodyPr wrap="square" lIns="0" tIns="0" rIns="0" bIns="0" rtlCol="0" anchor="ctr"/>
-          <a:lstStyle/>
-          <a:p>
-            <a:pPr indent="0" marL="0">
-              <a:buNone/>
-            </a:pPr>
-            <a:r>
-              <a:rPr lang="en-US" sz="1100" b="1" dirty="0">
-                <a:solidFill>
-                  <a:srgbClr val="0A1F44"/>
-                </a:solidFill>
-                <a:latin typeface="Inter" pitchFamily="34" charset="0"/>
-                <a:ea typeface="Inter" pitchFamily="34" charset="-122"/>
-                <a:cs typeface="Inter" pitchFamily="34" charset="-120"/>
-              </a:rPr>
-              <a:t>The fixed $120M</a:t>
-            </a:r>
-            <a:endParaRPr lang="en-US" sz="1100" dirty="0"/>
-          </a:p>
-          <a:p>
-            <a:pPr indent="0" marL="0">
-              <a:buNone/>
-            </a:pPr>
-            <a:r>
-              <a:rPr lang="en-US" sz="850" dirty="0">
-                <a:solidFill>
-                  <a:srgbClr val="64748B"/>
-                </a:solidFill>
-                <a:latin typeface="Inter" pitchFamily="34" charset="0"/>
-                <a:ea typeface="Inter" pitchFamily="34" charset="-122"/>
-                <a:cs typeface="Inter" pitchFamily="34" charset="-120"/>
-              </a:rPr>
-              <a:t>$0 new money (Exhibit G)</a:t>
-            </a:r>
-            <a:endParaRPr lang="en-US" sz="1100" dirty="0"/>
-          </a:p>
-        </p:txBody>
-      </p:sp>
-      <p:sp>
-        <p:nvSpPr>
-          <p:cNvPr id="124" name="Shape 112"/>
-          <p:cNvSpPr/>
-          <p:nvPr/>
-        </p:nvSpPr>
-        <p:spPr>
-          <a:xfrm>
-            <a:off x="2057400" y="5788152"/>
-            <a:ext cx="3618738" cy="292608"/>
-          </a:xfrm>
-          <a:prstGeom prst="rect">
-            <a:avLst/>
-          </a:prstGeom>
-          <a:solidFill>
-            <a:srgbClr val="E2E8F0"/>
-          </a:solidFill>
-          <a:ln w="6350">
-            <a:solidFill>
-              <a:srgbClr val="E2E8F0"/>
-            </a:solidFill>
-            <a:prstDash val="solid"/>
-          </a:ln>
-        </p:spPr>
-      </p:sp>
-      <p:sp>
-        <p:nvSpPr>
-          <p:cNvPr id="125" name="Text 113"/>
-          <p:cNvSpPr txBox="1"/>
-          <p:nvPr/>
-        </p:nvSpPr>
-        <p:spPr>
-          <a:xfrm>
-            <a:off x="2084832" y="5788152"/>
-            <a:ext cx="3591306" cy="292608"/>
-          </a:xfrm>
-          <a:prstGeom prst="rect">
-            <a:avLst/>
-          </a:prstGeom>
-          <a:noFill/>
-          <a:ln/>
-        </p:spPr>
-        <p:txBody>
-          <a:bodyPr wrap="square" lIns="0" tIns="0" rIns="0" bIns="0" rtlCol="0" anchor="ctr">
-            <a:normAutofit/>
-          </a:bodyPr>
-          <a:lstStyle/>
-          <a:p>
-            <a:pPr indent="0" marL="0">
-              <a:buNone/>
-            </a:pPr>
-            <a:r>
-              <a:rPr lang="en-US" sz="800" b="1" dirty="0">
-                <a:solidFill>
-                  <a:srgbClr val="334155"/>
-                </a:solidFill>
-                <a:latin typeface="Inter" pitchFamily="34" charset="0"/>
-                <a:ea typeface="Inter" pitchFamily="34" charset="-122"/>
-                <a:cs typeface="Inter" pitchFamily="34" charset="-120"/>
-              </a:rPr>
-              <a:t>Prospecting $58M</a:t>
-            </a:r>
-            <a:endParaRPr lang="en-US" sz="800" dirty="0"/>
-          </a:p>
-        </p:txBody>
-      </p:sp>
-      <p:sp>
-        <p:nvSpPr>
-          <p:cNvPr id="126" name="Text 114"/>
-          <p:cNvSpPr txBox="1"/>
-          <p:nvPr/>
-        </p:nvSpPr>
-        <p:spPr>
-          <a:xfrm>
-            <a:off x="2057400" y="6089904"/>
-            <a:ext cx="3646170" cy="182880"/>
-          </a:xfrm>
-          <a:prstGeom prst="rect">
-            <a:avLst/>
-          </a:prstGeom>
-          <a:noFill/>
-          <a:ln/>
-        </p:spPr>
-        <p:txBody>
-          <a:bodyPr wrap="square" lIns="0" tIns="0" rIns="0" bIns="0" rtlCol="0" anchor="t"/>
-          <a:lstStyle/>
-          <a:p>
-            <a:pPr algn="l" indent="0" marL="0">
-              <a:buNone/>
-            </a:pPr>
-            <a:r>
-              <a:rPr lang="en-US" sz="750" dirty="0">
-                <a:solidFill>
-                  <a:srgbClr val="64748B"/>
-                </a:solidFill>
-                <a:latin typeface="Inter" pitchFamily="34" charset="0"/>
-                <a:ea typeface="Inter" pitchFamily="34" charset="-122"/>
-                <a:cs typeface="Inter" pitchFamily="34" charset="-120"/>
-              </a:rPr>
-              <a:t>unchanged</a:t>
-            </a:r>
-            <a:endParaRPr lang="en-US" sz="750" dirty="0"/>
-          </a:p>
-        </p:txBody>
-      </p:sp>
-      <p:sp>
-        <p:nvSpPr>
-          <p:cNvPr id="127" name="Shape 115"/>
-          <p:cNvSpPr/>
-          <p:nvPr/>
-        </p:nvSpPr>
-        <p:spPr>
-          <a:xfrm>
-            <a:off x="5703570" y="5788152"/>
-            <a:ext cx="1355598" cy="292608"/>
-          </a:xfrm>
-          <a:prstGeom prst="rect">
-            <a:avLst/>
-          </a:prstGeom>
-          <a:solidFill>
-            <a:srgbClr val="E2E8F0"/>
-          </a:solidFill>
-          <a:ln w="6350">
-            <a:solidFill>
-              <a:srgbClr val="E2E8F0"/>
-            </a:solidFill>
-            <a:prstDash val="solid"/>
-          </a:ln>
-        </p:spPr>
-      </p:sp>
-      <p:sp>
-        <p:nvSpPr>
-          <p:cNvPr id="128" name="Text 116"/>
-          <p:cNvSpPr txBox="1"/>
-          <p:nvPr/>
-        </p:nvSpPr>
-        <p:spPr>
-          <a:xfrm>
-            <a:off x="5731002" y="5788152"/>
-            <a:ext cx="1328166" cy="292608"/>
-          </a:xfrm>
-          <a:prstGeom prst="rect">
-            <a:avLst/>
-          </a:prstGeom>
-          <a:noFill/>
-          <a:ln/>
-        </p:spPr>
-        <p:txBody>
-          <a:bodyPr wrap="square" lIns="0" tIns="0" rIns="0" bIns="0" rtlCol="0" anchor="ctr">
-            <a:normAutofit/>
-          </a:bodyPr>
-          <a:lstStyle/>
-          <a:p>
-            <a:pPr indent="0" marL="0">
-              <a:buNone/>
-            </a:pPr>
-            <a:r>
-              <a:rPr lang="en-US" sz="800" b="1" dirty="0">
-                <a:solidFill>
-                  <a:srgbClr val="334155"/>
-                </a:solidFill>
-                <a:latin typeface="Inter" pitchFamily="34" charset="0"/>
-                <a:ea typeface="Inter" pitchFamily="34" charset="-122"/>
-                <a:cs typeface="Inter" pitchFamily="34" charset="-120"/>
-              </a:rPr>
-              <a:t>Search $22M</a:t>
-            </a:r>
-            <a:endParaRPr lang="en-US" sz="800" dirty="0"/>
-          </a:p>
-        </p:txBody>
-      </p:sp>
-      <p:sp>
-        <p:nvSpPr>
-          <p:cNvPr id="129" name="Text 117"/>
-          <p:cNvSpPr txBox="1"/>
-          <p:nvPr/>
-        </p:nvSpPr>
-        <p:spPr>
-          <a:xfrm>
-            <a:off x="5703570" y="6089904"/>
-            <a:ext cx="1383030" cy="182880"/>
-          </a:xfrm>
-          <a:prstGeom prst="rect">
-            <a:avLst/>
-          </a:prstGeom>
-          <a:noFill/>
-          <a:ln/>
-        </p:spPr>
-        <p:txBody>
-          <a:bodyPr wrap="square" lIns="0" tIns="0" rIns="0" bIns="0" rtlCol="0" anchor="t"/>
-          <a:lstStyle/>
-          <a:p>
-            <a:pPr algn="l" indent="0" marL="0">
-              <a:buNone/>
-            </a:pPr>
-            <a:r>
-              <a:rPr lang="en-US" sz="750" dirty="0">
-                <a:solidFill>
-                  <a:srgbClr val="64748B"/>
-                </a:solidFill>
-                <a:latin typeface="Inter" pitchFamily="34" charset="0"/>
-                <a:ea typeface="Inter" pitchFamily="34" charset="-122"/>
-                <a:cs typeface="Inter" pitchFamily="34" charset="-120"/>
-              </a:rPr>
-              <a:t>unchanged</a:t>
-            </a:r>
-            <a:endParaRPr lang="en-US" sz="750" dirty="0"/>
-          </a:p>
-        </p:txBody>
-      </p:sp>
-      <p:sp>
-        <p:nvSpPr>
-          <p:cNvPr id="130" name="Shape 118"/>
-          <p:cNvSpPr/>
-          <p:nvPr/>
-        </p:nvSpPr>
-        <p:spPr>
-          <a:xfrm>
-            <a:off x="7086600" y="5788152"/>
-            <a:ext cx="978408" cy="292608"/>
-          </a:xfrm>
-          <a:prstGeom prst="rect">
-            <a:avLst/>
-          </a:prstGeom>
-          <a:solidFill>
-            <a:srgbClr val="CBD5E1"/>
-          </a:solidFill>
-          <a:ln w="6350">
-            <a:solidFill>
-              <a:srgbClr val="CBD5E1"/>
-            </a:solidFill>
-            <a:prstDash val="solid"/>
-          </a:ln>
-        </p:spPr>
-      </p:sp>
-      <p:sp>
-        <p:nvSpPr>
-          <p:cNvPr id="131" name="Text 119"/>
-          <p:cNvSpPr txBox="1"/>
-          <p:nvPr/>
-        </p:nvSpPr>
-        <p:spPr>
-          <a:xfrm>
-            <a:off x="7114032" y="5788152"/>
-            <a:ext cx="950976" cy="292608"/>
-          </a:xfrm>
-          <a:prstGeom prst="rect">
-            <a:avLst/>
-          </a:prstGeom>
-          <a:noFill/>
-          <a:ln/>
-        </p:spPr>
-        <p:txBody>
-          <a:bodyPr wrap="square" lIns="0" tIns="0" rIns="0" bIns="0" rtlCol="0" anchor="ctr">
-            <a:normAutofit/>
-          </a:bodyPr>
-          <a:lstStyle/>
-          <a:p>
-            <a:pPr indent="0" marL="0">
-              <a:buNone/>
-            </a:pPr>
-            <a:r>
-              <a:rPr lang="en-US" sz="800" b="1" dirty="0">
-                <a:solidFill>
-                  <a:srgbClr val="0A1F44"/>
-                </a:solidFill>
-                <a:latin typeface="Inter" pitchFamily="34" charset="0"/>
-                <a:ea typeface="Inter" pitchFamily="34" charset="-122"/>
-                <a:cs typeface="Inter" pitchFamily="34" charset="-120"/>
-              </a:rPr>
-              <a:t>Influencer $16M</a:t>
-            </a:r>
-            <a:endParaRPr lang="en-US" sz="800" dirty="0"/>
-          </a:p>
-        </p:txBody>
-      </p:sp>
-      <p:sp>
-        <p:nvSpPr>
-          <p:cNvPr id="132" name="Text 120"/>
-          <p:cNvSpPr txBox="1"/>
-          <p:nvPr/>
-        </p:nvSpPr>
-        <p:spPr>
-          <a:xfrm>
-            <a:off x="7086600" y="6089904"/>
-            <a:ext cx="1188720" cy="182880"/>
-          </a:xfrm>
-          <a:prstGeom prst="rect">
-            <a:avLst/>
-          </a:prstGeom>
-          <a:noFill/>
-          <a:ln/>
-        </p:spPr>
-        <p:txBody>
-          <a:bodyPr wrap="square" lIns="0" tIns="0" rIns="0" bIns="0" rtlCol="0" anchor="t"/>
-          <a:lstStyle/>
-          <a:p>
-            <a:pPr algn="l" indent="0" marL="0">
-              <a:buNone/>
-            </a:pPr>
-            <a:r>
-              <a:rPr lang="en-US" sz="750" dirty="0">
-                <a:solidFill>
-                  <a:srgbClr val="64748B"/>
-                </a:solidFill>
-                <a:latin typeface="Inter" pitchFamily="34" charset="0"/>
-                <a:ea typeface="Inter" pitchFamily="34" charset="-122"/>
-                <a:cs typeface="Inter" pitchFamily="34" charset="-120"/>
-              </a:rPr>
-              <a:t>briefs → proof</a:t>
-            </a:r>
-            <a:endParaRPr lang="en-US" sz="750" dirty="0"/>
-          </a:p>
-        </p:txBody>
-      </p:sp>
-      <p:sp>
-        <p:nvSpPr>
-          <p:cNvPr id="133" name="Shape 121"/>
-          <p:cNvSpPr/>
-          <p:nvPr/>
-        </p:nvSpPr>
-        <p:spPr>
-          <a:xfrm>
-            <a:off x="8092440" y="5788152"/>
-            <a:ext cx="852678" cy="292608"/>
-          </a:xfrm>
-          <a:prstGeom prst="rect">
-            <a:avLst/>
-          </a:prstGeom>
-          <a:solidFill>
-            <a:srgbClr val="1D4ED8"/>
-          </a:solidFill>
-          <a:ln w="6350">
-            <a:solidFill>
-              <a:srgbClr val="1D4ED8"/>
-            </a:solidFill>
-            <a:prstDash val="solid"/>
-          </a:ln>
-        </p:spPr>
-      </p:sp>
-      <p:sp>
-        <p:nvSpPr>
-          <p:cNvPr id="134" name="Text 122"/>
-          <p:cNvSpPr txBox="1"/>
-          <p:nvPr/>
-        </p:nvSpPr>
-        <p:spPr>
-          <a:xfrm>
-            <a:off x="8119872" y="5788152"/>
-            <a:ext cx="825246" cy="292608"/>
-          </a:xfrm>
-          <a:prstGeom prst="rect">
-            <a:avLst/>
-          </a:prstGeom>
-          <a:noFill/>
-          <a:ln/>
-        </p:spPr>
-        <p:txBody>
-          <a:bodyPr wrap="square" lIns="0" tIns="0" rIns="0" bIns="0" rtlCol="0" anchor="ctr">
-            <a:normAutofit/>
-          </a:bodyPr>
-          <a:lstStyle/>
-          <a:p>
-            <a:pPr indent="0" marL="0">
-              <a:buNone/>
-            </a:pPr>
-            <a:r>
-              <a:rPr lang="en-US" sz="800" b="1" dirty="0">
-                <a:solidFill>
-                  <a:srgbClr val="FFFFFF"/>
-                </a:solidFill>
-                <a:latin typeface="Inter" pitchFamily="34" charset="0"/>
-                <a:ea typeface="Inter" pitchFamily="34" charset="-122"/>
-                <a:cs typeface="Inter" pitchFamily="34" charset="-120"/>
-              </a:rPr>
-              <a:t>Retarg. $14M</a:t>
-            </a:r>
-            <a:endParaRPr lang="en-US" sz="800" dirty="0"/>
-          </a:p>
-        </p:txBody>
-      </p:sp>
-      <p:sp>
-        <p:nvSpPr>
-          <p:cNvPr id="135" name="Text 123"/>
-          <p:cNvSpPr txBox="1"/>
-          <p:nvPr/>
-        </p:nvSpPr>
-        <p:spPr>
-          <a:xfrm>
-            <a:off x="8092440" y="6089904"/>
-            <a:ext cx="1188720" cy="182880"/>
-          </a:xfrm>
-          <a:prstGeom prst="rect">
-            <a:avLst/>
-          </a:prstGeom>
-          <a:noFill/>
-          <a:ln/>
-        </p:spPr>
-        <p:txBody>
-          <a:bodyPr wrap="square" lIns="0" tIns="0" rIns="0" bIns="0" rtlCol="0" anchor="t"/>
-          <a:lstStyle/>
-          <a:p>
-            <a:pPr algn="l" indent="0" marL="0">
-              <a:buNone/>
-            </a:pPr>
-            <a:r>
-              <a:rPr lang="en-US" sz="750" b="1" dirty="0">
-                <a:solidFill>
-                  <a:srgbClr val="1D4ED8"/>
-                </a:solidFill>
-                <a:latin typeface="Inter" pitchFamily="34" charset="0"/>
-                <a:ea typeface="Inter" pitchFamily="34" charset="-122"/>
-                <a:cs typeface="Inter" pitchFamily="34" charset="-120"/>
-              </a:rPr>
-              <a:t>lever 3</a:t>
-            </a:r>
-            <a:endParaRPr lang="en-US" sz="750" dirty="0"/>
-          </a:p>
-        </p:txBody>
-      </p:sp>
-      <p:sp>
-        <p:nvSpPr>
-          <p:cNvPr id="136" name="Shape 124"/>
-          <p:cNvSpPr/>
-          <p:nvPr/>
-        </p:nvSpPr>
-        <p:spPr>
-          <a:xfrm>
-            <a:off x="8972550" y="5788152"/>
-            <a:ext cx="349758" cy="292608"/>
-          </a:xfrm>
-          <a:prstGeom prst="rect">
-            <a:avLst/>
+          <p:cNvPr id="123" name="Shape 111"/>
+          <p:cNvSpPr/>
+          <p:nvPr/>
+        </p:nvSpPr>
+        <p:spPr>
+          <a:xfrm>
+            <a:off x="502920" y="5788152"/>
+            <a:ext cx="1783080" cy="603504"/>
+          </a:xfrm>
+          <a:prstGeom prst="roundRect">
+            <a:avLst>
+              <a:gd name="adj" fmla="val 9091"/>
+            </a:avLst>
           </a:prstGeom>
           <a:solidFill>
             <a:srgbClr val="0A1F44"/>
@@ -52103,32 +51629,30 @@
       </p:sp>
       <p:sp>
         <p:nvSpPr>
-          <p:cNvPr id="137" name="Text 125"/>
-          <p:cNvSpPr txBox="1"/>
-          <p:nvPr/>
-        </p:nvSpPr>
-        <p:spPr>
-          <a:xfrm>
-            <a:off x="8999982" y="5788152"/>
-            <a:ext cx="322326" cy="292608"/>
-          </a:xfrm>
-          <a:prstGeom prst="rect">
-            <a:avLst/>
-          </a:prstGeom>
-          <a:noFill/>
-          <a:ln/>
-        </p:spPr>
-        <p:txBody>
-          <a:bodyPr wrap="square" lIns="0" tIns="0" rIns="0" bIns="0" rtlCol="0" anchor="ctr">
-            <a:normAutofit/>
-          </a:bodyPr>
-          <a:lstStyle/>
-          <a:p>
-            <a:pPr indent="0" marL="0">
-              <a:buNone/>
-            </a:pPr>
-            <a:r>
-              <a:rPr lang="en-US" sz="650" b="1" dirty="0">
+          <p:cNvPr id="124" name="Text 112"/>
+          <p:cNvSpPr txBox="1"/>
+          <p:nvPr/>
+        </p:nvSpPr>
+        <p:spPr>
+          <a:xfrm>
+            <a:off x="603504" y="5788152"/>
+            <a:ext cx="1645920" cy="603504"/>
+          </a:xfrm>
+          <a:prstGeom prst="rect">
+            <a:avLst/>
+          </a:prstGeom>
+          <a:noFill/>
+          <a:ln/>
+        </p:spPr>
+        <p:txBody>
+          <a:bodyPr wrap="square" lIns="0" tIns="0" rIns="0" bIns="0" rtlCol="0" anchor="ctr"/>
+          <a:lstStyle/>
+          <a:p>
+            <a:pPr indent="0" marL="0">
+              <a:buNone/>
+            </a:pPr>
+            <a:r>
+              <a:rPr lang="en-US" sz="1100" b="1" dirty="0">
                 <a:solidFill>
                   <a:srgbClr val="FFFFFF"/>
                 </a:solidFill>
@@ -52136,90 +51660,337 @@
                 <a:ea typeface="Inter" pitchFamily="34" charset="-122"/>
                 <a:cs typeface="Inter" pitchFamily="34" charset="-120"/>
               </a:rPr>
-              <a:t>Owned $6M</a:t>
-            </a:r>
-            <a:endParaRPr lang="en-US" sz="650" dirty="0"/>
-          </a:p>
-        </p:txBody>
-      </p:sp>
-      <p:sp>
-        <p:nvSpPr>
-          <p:cNvPr id="138" name="Text 126"/>
-          <p:cNvSpPr txBox="1"/>
-          <p:nvPr/>
-        </p:nvSpPr>
-        <p:spPr>
-          <a:xfrm>
-            <a:off x="8618220" y="6089904"/>
-            <a:ext cx="731520" cy="182880"/>
-          </a:xfrm>
-          <a:prstGeom prst="rect">
-            <a:avLst/>
-          </a:prstGeom>
-          <a:noFill/>
-          <a:ln/>
-        </p:spPr>
-        <p:txBody>
-          <a:bodyPr wrap="square" lIns="0" tIns="0" rIns="0" bIns="0" rtlCol="0" anchor="t"/>
-          <a:lstStyle/>
-          <a:p>
-            <a:pPr algn="r" indent="0" marL="0">
-              <a:buNone/>
-            </a:pPr>
-            <a:r>
-              <a:rPr lang="en-US" sz="750" b="1" dirty="0">
-                <a:solidFill>
-                  <a:srgbClr val="1D4ED8"/>
-                </a:solidFill>
-                <a:latin typeface="Inter" pitchFamily="34" charset="0"/>
-                <a:ea typeface="Inter" pitchFamily="34" charset="-122"/>
-                <a:cs typeface="Inter" pitchFamily="34" charset="-120"/>
-              </a:rPr>
-              <a:t>levers 1–2</a:t>
-            </a:r>
-            <a:endParaRPr lang="en-US" sz="750" dirty="0"/>
-          </a:p>
-        </p:txBody>
-      </p:sp>
-      <p:sp>
-        <p:nvSpPr>
-          <p:cNvPr id="139" name="Shape 127"/>
-          <p:cNvSpPr/>
-          <p:nvPr/>
-        </p:nvSpPr>
-        <p:spPr>
-          <a:xfrm>
-            <a:off x="9349740" y="5788152"/>
-            <a:ext cx="224028" cy="292608"/>
-          </a:xfrm>
-          <a:prstGeom prst="rect">
+              <a:t>Rented → owned</a:t>
+            </a:r>
+            <a:endParaRPr lang="en-US" sz="1200" dirty="0"/>
+          </a:p>
+          <a:p>
+            <a:pPr indent="0" marL="0">
+              <a:buNone/>
+            </a:pPr>
+            <a:r>
+              <a:rPr lang="en-US" sz="850" dirty="0">
+                <a:solidFill>
+                  <a:srgbClr val="C7D7F5"/>
+                </a:solidFill>
+                <a:latin typeface="Inter" pitchFamily="34" charset="0"/>
+                <a:ea typeface="Inter" pitchFamily="34" charset="-122"/>
+                <a:cs typeface="Inter" pitchFamily="34" charset="-120"/>
+              </a:rPr>
+              <a:t>inside the fixed $120M</a:t>
+            </a:r>
+            <a:endParaRPr lang="en-US" sz="1200" dirty="0"/>
+          </a:p>
+        </p:txBody>
+      </p:sp>
+      <p:sp>
+        <p:nvSpPr>
+          <p:cNvPr id="125" name="Shape 113"/>
+          <p:cNvSpPr/>
+          <p:nvPr/>
+        </p:nvSpPr>
+        <p:spPr>
+          <a:xfrm>
+            <a:off x="2377440" y="5788152"/>
+            <a:ext cx="2578608" cy="603504"/>
+          </a:xfrm>
+          <a:prstGeom prst="chevron">
             <a:avLst/>
           </a:prstGeom>
           <a:solidFill>
-            <a:srgbClr val="F1F5F9"/>
+            <a:srgbClr val="1D4ED8"/>
           </a:solidFill>
-          <a:ln w="6350">
-            <a:solidFill>
-              <a:srgbClr val="F1F5F9"/>
-            </a:solidFill>
-            <a:prstDash val="solid"/>
-          </a:ln>
-        </p:spPr>
-      </p:sp>
-      <p:sp>
-        <p:nvSpPr>
-          <p:cNvPr id="140" name="Shape 128"/>
-          <p:cNvSpPr/>
-          <p:nvPr/>
-        </p:nvSpPr>
-        <p:spPr>
-          <a:xfrm>
-            <a:off x="9747504" y="5751576"/>
-            <a:ext cx="1938528" cy="548640"/>
+          <a:ln w="12700">
+            <a:solidFill>
+              <a:srgbClr val="FFFFFF"/>
+            </a:solidFill>
+            <a:prstDash val="solid"/>
+          </a:ln>
+        </p:spPr>
+      </p:sp>
+      <p:sp>
+        <p:nvSpPr>
+          <p:cNvPr id="126" name="Text 114"/>
+          <p:cNvSpPr txBox="1"/>
+          <p:nvPr/>
+        </p:nvSpPr>
+        <p:spPr>
+          <a:xfrm>
+            <a:off x="2688336" y="5788152"/>
+            <a:ext cx="2029968" cy="603504"/>
+          </a:xfrm>
+          <a:prstGeom prst="rect">
+            <a:avLst/>
+          </a:prstGeom>
+          <a:noFill/>
+          <a:ln/>
+        </p:spPr>
+        <p:txBody>
+          <a:bodyPr wrap="square" lIns="0" tIns="0" rIns="0" bIns="0" rtlCol="0" anchor="ctr"/>
+          <a:lstStyle/>
+          <a:p>
+            <a:pPr indent="0" marL="0">
+              <a:buNone/>
+            </a:pPr>
+            <a:r>
+              <a:rPr lang="en-US" sz="800" b="1" dirty="0">
+                <a:solidFill>
+                  <a:srgbClr val="DCE7FB"/>
+                </a:solidFill>
+                <a:latin typeface="Inter" pitchFamily="34" charset="0"/>
+                <a:ea typeface="Inter" pitchFamily="34" charset="-122"/>
+                <a:cs typeface="Inter" pitchFamily="34" charset="-120"/>
+              </a:rPr>
+              <a:t>After day 90</a:t>
+            </a:r>
+            <a:endParaRPr lang="en-US" sz="1200" dirty="0"/>
+          </a:p>
+          <a:p>
+            <a:pPr indent="0" marL="0">
+              <a:buNone/>
+            </a:pPr>
+            <a:r>
+              <a:rPr lang="en-US" sz="1000" b="1" dirty="0">
+                <a:solidFill>
+                  <a:srgbClr val="FFFFFF"/>
+                </a:solidFill>
+                <a:latin typeface="Inter" pitchFamily="34" charset="0"/>
+                <a:ea typeface="Inter" pitchFamily="34" charset="-122"/>
+                <a:cs typeface="Inter" pitchFamily="34" charset="-120"/>
+              </a:rPr>
+              <a:t>Retargeting → owned</a:t>
+            </a:r>
+            <a:endParaRPr lang="en-US" sz="1200" dirty="0"/>
+          </a:p>
+          <a:p>
+            <a:pPr indent="0" marL="0">
+              <a:buNone/>
+            </a:pPr>
+            <a:r>
+              <a:rPr lang="en-US" sz="850" dirty="0">
+                <a:solidFill>
+                  <a:srgbClr val="FFFFFF"/>
+                </a:solidFill>
+                <a:latin typeface="Inter" pitchFamily="34" charset="0"/>
+                <a:ea typeface="Inter" pitchFamily="34" charset="-122"/>
+                <a:cs typeface="Inter" pitchFamily="34" charset="-120"/>
+              </a:rPr>
+              <a:t>up to $3.4M (24.5% × $14M)</a:t>
+            </a:r>
+            <a:endParaRPr lang="en-US" sz="1200" dirty="0"/>
+          </a:p>
+        </p:txBody>
+      </p:sp>
+      <p:sp>
+        <p:nvSpPr>
+          <p:cNvPr id="127" name="Shape 115"/>
+          <p:cNvSpPr/>
+          <p:nvPr/>
+        </p:nvSpPr>
+        <p:spPr>
+          <a:xfrm>
+            <a:off x="4919472" y="5788152"/>
+            <a:ext cx="2578608" cy="603504"/>
+          </a:xfrm>
+          <a:prstGeom prst="chevron">
+            <a:avLst/>
+          </a:prstGeom>
+          <a:solidFill>
+            <a:srgbClr val="2563EB"/>
+          </a:solidFill>
+          <a:ln w="12700">
+            <a:solidFill>
+              <a:srgbClr val="FFFFFF"/>
+            </a:solidFill>
+            <a:prstDash val="solid"/>
+          </a:ln>
+        </p:spPr>
+      </p:sp>
+      <p:sp>
+        <p:nvSpPr>
+          <p:cNvPr id="128" name="Text 116"/>
+          <p:cNvSpPr txBox="1"/>
+          <p:nvPr/>
+        </p:nvSpPr>
+        <p:spPr>
+          <a:xfrm>
+            <a:off x="5230368" y="5788152"/>
+            <a:ext cx="2029968" cy="603504"/>
+          </a:xfrm>
+          <a:prstGeom prst="rect">
+            <a:avLst/>
+          </a:prstGeom>
+          <a:noFill/>
+          <a:ln/>
+        </p:spPr>
+        <p:txBody>
+          <a:bodyPr wrap="square" lIns="0" tIns="0" rIns="0" bIns="0" rtlCol="0" anchor="ctr"/>
+          <a:lstStyle/>
+          <a:p>
+            <a:pPr indent="0" marL="0">
+              <a:buNone/>
+            </a:pPr>
+            <a:r>
+              <a:rPr lang="en-US" sz="800" b="1" dirty="0">
+                <a:solidFill>
+                  <a:srgbClr val="DCE7FB"/>
+                </a:solidFill>
+                <a:latin typeface="Inter" pitchFamily="34" charset="0"/>
+                <a:ea typeface="Inter" pitchFamily="34" charset="-122"/>
+                <a:cs typeface="Inter" pitchFamily="34" charset="-120"/>
+              </a:rPr>
+              <a:t>Months 4–6</a:t>
+            </a:r>
+            <a:endParaRPr lang="en-US" sz="1200" dirty="0"/>
+          </a:p>
+          <a:p>
+            <a:pPr indent="0" marL="0">
+              <a:buNone/>
+            </a:pPr>
+            <a:r>
+              <a:rPr lang="en-US" sz="1000" b="1" dirty="0">
+                <a:solidFill>
+                  <a:srgbClr val="FFFFFF"/>
+                </a:solidFill>
+                <a:latin typeface="Inter" pitchFamily="34" charset="0"/>
+                <a:ea typeface="Inter" pitchFamily="34" charset="-122"/>
+                <a:cs typeface="Inter" pitchFamily="34" charset="-120"/>
+              </a:rPr>
+              <a:t>Branded search → owned</a:t>
+            </a:r>
+            <a:endParaRPr lang="en-US" sz="1200" dirty="0"/>
+          </a:p>
+          <a:p>
+            <a:pPr indent="0" marL="0">
+              <a:buNone/>
+            </a:pPr>
+            <a:r>
+              <a:rPr lang="en-US" sz="850" dirty="0">
+                <a:solidFill>
+                  <a:srgbClr val="FFFFFF"/>
+                </a:solidFill>
+                <a:latin typeface="Inter" pitchFamily="34" charset="0"/>
+                <a:ea typeface="Inter" pitchFamily="34" charset="-122"/>
+                <a:cs typeface="Inter" pitchFamily="34" charset="-120"/>
+              </a:rPr>
+              <a:t>test ~$6.2M (South 28% × $22M)</a:t>
+            </a:r>
+            <a:endParaRPr lang="en-US" sz="1200" dirty="0"/>
+          </a:p>
+        </p:txBody>
+      </p:sp>
+      <p:sp>
+        <p:nvSpPr>
+          <p:cNvPr id="129" name="Shape 117"/>
+          <p:cNvSpPr/>
+          <p:nvPr/>
+        </p:nvSpPr>
+        <p:spPr>
+          <a:xfrm>
+            <a:off x="7461504" y="5788152"/>
+            <a:ext cx="2578608" cy="603504"/>
+          </a:xfrm>
+          <a:prstGeom prst="chevron">
+            <a:avLst/>
+          </a:prstGeom>
+          <a:solidFill>
+            <a:srgbClr val="60A5FA"/>
+          </a:solidFill>
+          <a:ln w="12700">
+            <a:solidFill>
+              <a:srgbClr val="FFFFFF"/>
+            </a:solidFill>
+            <a:prstDash val="solid"/>
+          </a:ln>
+        </p:spPr>
+      </p:sp>
+      <p:sp>
+        <p:nvSpPr>
+          <p:cNvPr id="130" name="Text 118"/>
+          <p:cNvSpPr txBox="1"/>
+          <p:nvPr/>
+        </p:nvSpPr>
+        <p:spPr>
+          <a:xfrm>
+            <a:off x="7772400" y="5788152"/>
+            <a:ext cx="2029968" cy="603504"/>
+          </a:xfrm>
+          <a:prstGeom prst="rect">
+            <a:avLst/>
+          </a:prstGeom>
+          <a:noFill/>
+          <a:ln/>
+        </p:spPr>
+        <p:txBody>
+          <a:bodyPr wrap="square" lIns="0" tIns="0" rIns="0" bIns="0" rtlCol="0" anchor="ctr"/>
+          <a:lstStyle/>
+          <a:p>
+            <a:pPr indent="0" marL="0">
+              <a:buNone/>
+            </a:pPr>
+            <a:r>
+              <a:rPr lang="en-US" sz="800" b="1" dirty="0">
+                <a:solidFill>
+                  <a:srgbClr val="DCE7FB"/>
+                </a:solidFill>
+                <a:latin typeface="Inter" pitchFamily="34" charset="0"/>
+                <a:ea typeface="Inter" pitchFamily="34" charset="-122"/>
+                <a:cs typeface="Inter" pitchFamily="34" charset="-120"/>
+              </a:rPr>
+              <a:t>Months 7–9</a:t>
+            </a:r>
+            <a:endParaRPr lang="en-US" sz="1200" dirty="0"/>
+          </a:p>
+          <a:p>
+            <a:pPr indent="0" marL="0">
+              <a:buNone/>
+            </a:pPr>
+            <a:r>
+              <a:rPr lang="en-US" sz="1000" b="1" dirty="0">
+                <a:solidFill>
+                  <a:srgbClr val="FFFFFF"/>
+                </a:solidFill>
+                <a:latin typeface="Inter" pitchFamily="34" charset="0"/>
+                <a:ea typeface="Inter" pitchFamily="34" charset="-122"/>
+                <a:cs typeface="Inter" pitchFamily="34" charset="-120"/>
+              </a:rPr>
+              <a:t>Prospecting → owned</a:t>
+            </a:r>
+            <a:endParaRPr lang="en-US" sz="1200" dirty="0"/>
+          </a:p>
+          <a:p>
+            <a:pPr indent="0" marL="0">
+              <a:buNone/>
+            </a:pPr>
+            <a:r>
+              <a:rPr lang="en-US" sz="850" dirty="0">
+                <a:solidFill>
+                  <a:srgbClr val="FFFFFF"/>
+                </a:solidFill>
+                <a:latin typeface="Inter" pitchFamily="34" charset="0"/>
+                <a:ea typeface="Inter" pitchFamily="34" charset="-122"/>
+                <a:cs typeface="Inter" pitchFamily="34" charset="-120"/>
+              </a:rPr>
+              <a:t>test ~$16.2M (South 28% × $58M)</a:t>
+            </a:r>
+            <a:endParaRPr lang="en-US" sz="1200" dirty="0"/>
+          </a:p>
+        </p:txBody>
+      </p:sp>
+      <p:sp>
+        <p:nvSpPr>
+          <p:cNvPr id="131" name="Shape 119"/>
+          <p:cNvSpPr/>
+          <p:nvPr/>
+        </p:nvSpPr>
+        <p:spPr>
+          <a:xfrm>
+            <a:off x="9747504" y="5788152"/>
+            <a:ext cx="1938528" cy="603504"/>
           </a:xfrm>
           <a:prstGeom prst="roundRect">
             <a:avLst>
-              <a:gd name="adj" fmla="val 10000"/>
+              <a:gd name="adj" fmla="val 9091"/>
             </a:avLst>
           </a:prstGeom>
           <a:solidFill>
@@ -52235,14 +52006,14 @@
       </p:sp>
       <p:sp>
         <p:nvSpPr>
-          <p:cNvPr id="141" name="Text 129"/>
-          <p:cNvSpPr txBox="1"/>
-          <p:nvPr/>
-        </p:nvSpPr>
-        <p:spPr>
-          <a:xfrm>
-            <a:off x="9838944" y="5751576"/>
-            <a:ext cx="1801368" cy="548640"/>
+          <p:cNvPr id="132" name="Text 120"/>
+          <p:cNvSpPr txBox="1"/>
+          <p:nvPr/>
+        </p:nvSpPr>
+        <p:spPr>
+          <a:xfrm>
+            <a:off x="9838944" y="5788152"/>
+            <a:ext cx="1801368" cy="603504"/>
           </a:xfrm>
           <a:prstGeom prst="rect">
             <a:avLst/>
@@ -52258,6 +52029,20 @@
               <a:buNone/>
             </a:pPr>
             <a:r>
+              <a:rPr lang="en-US" sz="850" dirty="0">
+                <a:solidFill>
+                  <a:srgbClr val="0F172A"/>
+                </a:solidFill>
+                <a:latin typeface="Inter" pitchFamily="34" charset="0"/>
+                <a:ea typeface="Inter" pitchFamily="34" charset="-122"/>
+                <a:cs typeface="Inter" pitchFamily="34" charset="-120"/>
+              </a:rPr>
+              <a:t>Each step moves only </a:t>
+            </a:r>
+            <a:pPr indent="0" marL="0">
+              <a:buNone/>
+            </a:pPr>
+            <a:r>
               <a:rPr lang="en-US" sz="850" b="1" dirty="0">
                 <a:solidFill>
                   <a:srgbClr val="0A1F44"/>
@@ -52266,7 +52051,7 @@
                 <a:ea typeface="Inter" pitchFamily="34" charset="-122"/>
                 <a:cs typeface="Inter" pitchFamily="34" charset="-120"/>
               </a:rPr>
-              <a:t>Day 90: </a:t>
+              <a:t>what its holdout proves</a:t>
             </a:r>
             <a:pPr indent="0" marL="0">
               <a:buNone/>
@@ -52280,7 +52065,7 @@
                 <a:ea typeface="Inter" pitchFamily="34" charset="-122"/>
                 <a:cs typeface="Inter" pitchFamily="34" charset="-120"/>
               </a:rPr>
-              <a:t>scale, adjust or stop; any move across lines is sized by the holdout</a:t>
+              <a:t>; scale, adjust or stop</a:t>
             </a:r>
             <a:endParaRPr lang="en-US" sz="850" dirty="0"/>
           </a:p>

</xml_diff>